<commit_message>
Thumbnail Programmieren: Titel 'So lernst du richtig programmieren' prominent
Co-Authored-By: Claude Sonnet 5.5 <noreply@anthropic.com>
Claude-Session: https://claude.ai/code/session_0139kriXJ67p3UvpR2gsSR9G
</commit_message>
<xml_diff>
--- a/videoslides/cleverbox-thumbnail-programmieren-denken.pptx
+++ b/videoslides/cleverbox-thumbnail-programmieren-denken.pptx
@@ -901,18 +901,57 @@
       </p:pic>
       <p:sp>
         <p:nvSpPr>
-          <p:cNvPr id="3" name="Tag-Fläche"/>
-          <p:cNvSpPr/>
-          <p:nvPr/>
-        </p:nvSpPr>
-        <p:spPr>
-          <a:xfrm>
-            <a:off x="571500" y="666750"/>
-            <a:ext cx="3327053" cy="533400"/>
+          <p:cNvPr id="3" name="Titel 1"/>
+          <p:cNvSpPr txBox="1"/>
+          <p:nvPr/>
+        </p:nvSpPr>
+        <p:spPr>
+          <a:xfrm>
+            <a:off x="476250" y="247650"/>
+            <a:ext cx="11430000" cy="1047750"/>
+          </a:xfrm>
+          <a:prstGeom prst="rect">
+            <a:avLst/>
+          </a:prstGeom>
+          <a:noFill/>
+          <a:ln/>
+        </p:spPr>
+        <p:txBody>
+          <a:bodyPr wrap="none" lIns="0" tIns="0" rIns="0" bIns="0" rtlCol="0" anchor="ctr"/>
+          <a:lstStyle/>
+          <a:p>
+            <a:pPr algn="l" indent="0" marL="0">
+              <a:buNone/>
+            </a:pPr>
+            <a:r>
+              <a:rPr lang="en-US" sz="6800" b="1" i="1" dirty="0">
+                <a:solidFill>
+                  <a:srgbClr val="12301A"/>
+                </a:solidFill>
+                <a:latin typeface="Poppins" pitchFamily="34" charset="0"/>
+                <a:ea typeface="Poppins" pitchFamily="34" charset="-122"/>
+                <a:cs typeface="Poppins" pitchFamily="34" charset="-120"/>
+              </a:rPr>
+              <a:t>SO LERNST DU RICHTIG</a:t>
+            </a:r>
+            <a:endParaRPr lang="en-US" sz="6800" dirty="0"/>
+          </a:p>
+        </p:txBody>
+      </p:sp>
+      <p:sp>
+        <p:nvSpPr>
+          <p:cNvPr id="4" name="Marker-Balken"/>
+          <p:cNvSpPr/>
+          <p:nvPr/>
+        </p:nvSpPr>
+        <p:spPr>
+          <a:xfrm>
+            <a:off x="323850" y="1343025"/>
+            <a:ext cx="10958959" cy="1200150"/>
           </a:xfrm>
           <a:prstGeom prst="roundRect">
             <a:avLst>
-              <a:gd name="adj" fmla="val 24000"/>
+              <a:gd name="adj" fmla="val 13714"/>
             </a:avLst>
           </a:prstGeom>
           <a:solidFill>
@@ -928,14 +967,146 @@
       </p:sp>
       <p:sp>
         <p:nvSpPr>
-          <p:cNvPr id="4" name="Tag"/>
+          <p:cNvPr id="5" name="Titel 2"/>
           <p:cNvSpPr txBox="1"/>
           <p:nvPr/>
         </p:nvSpPr>
         <p:spPr>
           <a:xfrm>
-            <a:off x="571500" y="666750"/>
-            <a:ext cx="3327053" cy="533400"/>
+            <a:off x="476250" y="1257300"/>
+            <a:ext cx="11430000" cy="1314450"/>
+          </a:xfrm>
+          <a:prstGeom prst="rect">
+            <a:avLst/>
+          </a:prstGeom>
+          <a:noFill/>
+          <a:ln/>
+        </p:spPr>
+        <p:txBody>
+          <a:bodyPr wrap="none" lIns="0" tIns="0" rIns="0" bIns="0" rtlCol="0" anchor="ctr"/>
+          <a:lstStyle/>
+          <a:p>
+            <a:pPr algn="l" indent="0" marL="0">
+              <a:buNone/>
+            </a:pPr>
+            <a:r>
+              <a:rPr lang="en-US" sz="8400" b="1" i="1" dirty="0">
+                <a:solidFill>
+                  <a:srgbClr val="12301A"/>
+                </a:solidFill>
+                <a:latin typeface="Poppins" pitchFamily="34" charset="0"/>
+                <a:ea typeface="Poppins" pitchFamily="34" charset="-122"/>
+                <a:cs typeface="Poppins" pitchFamily="34" charset="-120"/>
+              </a:rPr>
+              <a:t>PROGRAMMIEREN</a:t>
+            </a:r>
+            <a:endParaRPr lang="en-US" sz="8400" dirty="0"/>
+          </a:p>
+        </p:txBody>
+      </p:sp>
+      <p:sp>
+        <p:nvSpPr>
+          <p:cNvPr id="6" name="Unterzeile-Fläche"/>
+          <p:cNvSpPr/>
+          <p:nvPr/>
+        </p:nvSpPr>
+        <p:spPr>
+          <a:xfrm>
+            <a:off x="476250" y="2781300"/>
+            <a:ext cx="6746379" cy="914400"/>
+          </a:xfrm>
+          <a:prstGeom prst="roundRect">
+            <a:avLst>
+              <a:gd name="adj" fmla="val 14000"/>
+            </a:avLst>
+          </a:prstGeom>
+          <a:solidFill>
+            <a:srgbClr val="12301A"/>
+          </a:solidFill>
+          <a:ln w="12700">
+            <a:solidFill>
+              <a:srgbClr val="12301A"/>
+            </a:solidFill>
+            <a:prstDash val="solid"/>
+          </a:ln>
+        </p:spPr>
+      </p:sp>
+      <p:sp>
+        <p:nvSpPr>
+          <p:cNvPr id="7" name="Unterzeile"/>
+          <p:cNvSpPr txBox="1"/>
+          <p:nvPr/>
+        </p:nvSpPr>
+        <p:spPr>
+          <a:xfrm>
+            <a:off x="742950" y="2781300"/>
+            <a:ext cx="6479679" cy="914400"/>
+          </a:xfrm>
+          <a:prstGeom prst="rect">
+            <a:avLst/>
+          </a:prstGeom>
+          <a:noFill/>
+          <a:ln/>
+        </p:spPr>
+        <p:txBody>
+          <a:bodyPr wrap="none" lIns="0" tIns="0" rIns="0" bIns="0" rtlCol="0" anchor="ctr"/>
+          <a:lstStyle/>
+          <a:p>
+            <a:pPr algn="l" indent="0" marL="0">
+              <a:buNone/>
+            </a:pPr>
+            <a:r>
+              <a:rPr lang="en-US" sz="4100" b="1" i="1" dirty="0">
+                <a:solidFill>
+                  <a:srgbClr val="B1FF37"/>
+                </a:solidFill>
+                <a:latin typeface="Poppins" pitchFamily="34" charset="0"/>
+                <a:ea typeface="Poppins" pitchFamily="34" charset="-122"/>
+                <a:cs typeface="Poppins" pitchFamily="34" charset="-120"/>
+              </a:rPr>
+              <a:t>DENKEN VOR SYNTAX</a:t>
+            </a:r>
+            <a:endParaRPr lang="en-US" sz="4100" dirty="0"/>
+          </a:p>
+        </p:txBody>
+      </p:sp>
+      <p:sp>
+        <p:nvSpPr>
+          <p:cNvPr id="8" name="Chip Karel the Robot"/>
+          <p:cNvSpPr/>
+          <p:nvPr/>
+        </p:nvSpPr>
+        <p:spPr>
+          <a:xfrm>
+            <a:off x="476250" y="3943350"/>
+            <a:ext cx="2622054" cy="590550"/>
+          </a:xfrm>
+          <a:prstGeom prst="roundRect">
+            <a:avLst>
+              <a:gd name="adj" fmla="val 21677"/>
+            </a:avLst>
+          </a:prstGeom>
+          <a:solidFill>
+            <a:srgbClr val="12301A"/>
+          </a:solidFill>
+          <a:ln w="12700">
+            <a:solidFill>
+              <a:srgbClr val="12301A"/>
+            </a:solidFill>
+            <a:prstDash val="solid"/>
+          </a:ln>
+        </p:spPr>
+      </p:sp>
+      <p:sp>
+        <p:nvSpPr>
+          <p:cNvPr id="9" name="Chip-Text Karel the Robot"/>
+          <p:cNvSpPr txBox="1"/>
+          <p:nvPr/>
+        </p:nvSpPr>
+        <p:spPr>
+          <a:xfrm>
+            <a:off x="476250" y="3943350"/>
+            <a:ext cx="2622054" cy="590550"/>
           </a:xfrm>
           <a:prstGeom prst="rect">
             <a:avLst/>
@@ -951,217 +1122,7 @@
               <a:buNone/>
             </a:pPr>
             <a:r>
-              <a:rPr lang="en-US" sz="1900" b="1" dirty="0">
-                <a:solidFill>
-                  <a:srgbClr val="12301A"/>
-                </a:solidFill>
-                <a:latin typeface="Poppins" pitchFamily="34" charset="0"/>
-                <a:ea typeface="Poppins" pitchFamily="34" charset="-122"/>
-                <a:cs typeface="Poppins" pitchFamily="34" charset="-120"/>
-              </a:rPr>
-              <a:t>Programmieren lernen</a:t>
-            </a:r>
-            <a:endParaRPr lang="en-US" sz="1900" dirty="0"/>
-          </a:p>
-        </p:txBody>
-      </p:sp>
-      <p:sp>
-        <p:nvSpPr>
-          <p:cNvPr id="5" name="Titel 1"/>
-          <p:cNvSpPr txBox="1"/>
-          <p:nvPr/>
-        </p:nvSpPr>
-        <p:spPr>
-          <a:xfrm>
-            <a:off x="571500" y="1428750"/>
-            <a:ext cx="6096000" cy="1304925"/>
-          </a:xfrm>
-          <a:prstGeom prst="rect">
-            <a:avLst/>
-          </a:prstGeom>
-          <a:noFill/>
-          <a:ln/>
-        </p:spPr>
-        <p:txBody>
-          <a:bodyPr wrap="none" lIns="0" tIns="0" rIns="0" bIns="0" rtlCol="0" anchor="ctr"/>
-          <a:lstStyle/>
-          <a:p>
-            <a:pPr algn="l" indent="0" marL="0">
-              <a:buNone/>
-            </a:pPr>
-            <a:r>
-              <a:rPr lang="en-US" sz="8200" b="1" i="1" dirty="0">
-                <a:solidFill>
-                  <a:srgbClr val="12301A"/>
-                </a:solidFill>
-                <a:latin typeface="Poppins" pitchFamily="34" charset="0"/>
-                <a:ea typeface="Poppins" pitchFamily="34" charset="-122"/>
-                <a:cs typeface="Poppins" pitchFamily="34" charset="-120"/>
-              </a:rPr>
-              <a:t>DENKEN</a:t>
-            </a:r>
-            <a:endParaRPr lang="en-US" sz="8200" dirty="0"/>
-          </a:p>
-        </p:txBody>
-      </p:sp>
-      <p:sp>
-        <p:nvSpPr>
-          <p:cNvPr id="6" name="Titel 2"/>
-          <p:cNvSpPr txBox="1"/>
-          <p:nvPr/>
-        </p:nvSpPr>
-        <p:spPr>
-          <a:xfrm>
-            <a:off x="571500" y="2733675"/>
-            <a:ext cx="6096000" cy="1304925"/>
-          </a:xfrm>
-          <a:prstGeom prst="rect">
-            <a:avLst/>
-          </a:prstGeom>
-          <a:noFill/>
-          <a:ln/>
-        </p:spPr>
-        <p:txBody>
-          <a:bodyPr wrap="none" lIns="0" tIns="0" rIns="0" bIns="0" rtlCol="0" anchor="ctr"/>
-          <a:lstStyle/>
-          <a:p>
-            <a:pPr algn="l" indent="0" marL="0">
-              <a:buNone/>
-            </a:pPr>
-            <a:r>
-              <a:rPr lang="en-US" sz="8200" b="1" i="1" dirty="0">
-                <a:solidFill>
-                  <a:srgbClr val="12301A"/>
-                </a:solidFill>
-                <a:latin typeface="Poppins" pitchFamily="34" charset="0"/>
-                <a:ea typeface="Poppins" pitchFamily="34" charset="-122"/>
-                <a:cs typeface="Poppins" pitchFamily="34" charset="-120"/>
-              </a:rPr>
-              <a:t>VOR</a:t>
-            </a:r>
-            <a:endParaRPr lang="en-US" sz="8200" dirty="0"/>
-          </a:p>
-        </p:txBody>
-      </p:sp>
-      <p:sp>
-        <p:nvSpPr>
-          <p:cNvPr id="7" name="Marker-Balken"/>
-          <p:cNvSpPr/>
-          <p:nvPr/>
-        </p:nvSpPr>
-        <p:spPr>
-          <a:xfrm>
-            <a:off x="419100" y="4152900"/>
-            <a:ext cx="5207347" cy="1171575"/>
-          </a:xfrm>
-          <a:prstGeom prst="roundRect">
-            <a:avLst>
-              <a:gd name="adj" fmla="val 14049"/>
-            </a:avLst>
-          </a:prstGeom>
-          <a:solidFill>
-            <a:srgbClr val="B1FF37"/>
-          </a:solidFill>
-          <a:ln w="12700">
-            <a:solidFill>
-              <a:srgbClr val="B1FF37"/>
-            </a:solidFill>
-            <a:prstDash val="solid"/>
-          </a:ln>
-        </p:spPr>
-      </p:sp>
-      <p:sp>
-        <p:nvSpPr>
-          <p:cNvPr id="8" name="Titel 3"/>
-          <p:cNvSpPr txBox="1"/>
-          <p:nvPr/>
-        </p:nvSpPr>
-        <p:spPr>
-          <a:xfrm>
-            <a:off x="571500" y="4038600"/>
-            <a:ext cx="6096000" cy="1304925"/>
-          </a:xfrm>
-          <a:prstGeom prst="rect">
-            <a:avLst/>
-          </a:prstGeom>
-          <a:noFill/>
-          <a:ln/>
-        </p:spPr>
-        <p:txBody>
-          <a:bodyPr wrap="none" lIns="0" tIns="0" rIns="0" bIns="0" rtlCol="0" anchor="ctr"/>
-          <a:lstStyle/>
-          <a:p>
-            <a:pPr algn="l" indent="0" marL="0">
-              <a:buNone/>
-            </a:pPr>
-            <a:r>
-              <a:rPr lang="en-US" sz="8200" b="1" i="1" dirty="0">
-                <a:solidFill>
-                  <a:srgbClr val="12301A"/>
-                </a:solidFill>
-                <a:latin typeface="Poppins" pitchFamily="34" charset="0"/>
-                <a:ea typeface="Poppins" pitchFamily="34" charset="-122"/>
-                <a:cs typeface="Poppins" pitchFamily="34" charset="-120"/>
-              </a:rPr>
-              <a:t>SYNTAX</a:t>
-            </a:r>
-            <a:endParaRPr lang="en-US" sz="8200" dirty="0"/>
-          </a:p>
-        </p:txBody>
-      </p:sp>
-      <p:sp>
-        <p:nvSpPr>
-          <p:cNvPr id="9" name="Chip 1"/>
-          <p:cNvSpPr/>
-          <p:nvPr/>
-        </p:nvSpPr>
-        <p:spPr>
-          <a:xfrm>
-            <a:off x="571500" y="5591175"/>
-            <a:ext cx="2299097" cy="495300"/>
-          </a:xfrm>
-          <a:prstGeom prst="roundRect">
-            <a:avLst>
-              <a:gd name="adj" fmla="val 25846"/>
-            </a:avLst>
-          </a:prstGeom>
-          <a:solidFill>
-            <a:srgbClr val="12301A"/>
-          </a:solidFill>
-          <a:ln w="12700">
-            <a:solidFill>
-              <a:srgbClr val="12301A"/>
-            </a:solidFill>
-            <a:prstDash val="solid"/>
-          </a:ln>
-        </p:spPr>
-      </p:sp>
-      <p:sp>
-        <p:nvSpPr>
-          <p:cNvPr id="10" name="Chip-Text 1"/>
-          <p:cNvSpPr txBox="1"/>
-          <p:nvPr/>
-        </p:nvSpPr>
-        <p:spPr>
-          <a:xfrm>
-            <a:off x="571500" y="5591175"/>
-            <a:ext cx="2299097" cy="495300"/>
-          </a:xfrm>
-          <a:prstGeom prst="rect">
-            <a:avLst/>
-          </a:prstGeom>
-          <a:noFill/>
-          <a:ln/>
-        </p:spPr>
-        <p:txBody>
-          <a:bodyPr wrap="none" lIns="0" tIns="0" rIns="0" bIns="0" rtlCol="0" anchor="ctr"/>
-          <a:lstStyle/>
-          <a:p>
-            <a:pPr algn="ctr" indent="0" marL="0">
-              <a:buNone/>
-            </a:pPr>
-            <a:r>
-              <a:rPr lang="en-US" sz="1900" b="1" dirty="0">
+              <a:rPr lang="en-US" sz="2200" b="1" dirty="0">
                 <a:solidFill>
                   <a:srgbClr val="B1FF37"/>
                 </a:solidFill>
@@ -1171,24 +1132,24 @@
               </a:rPr>
               <a:t>Karel the Robot</a:t>
             </a:r>
-            <a:endParaRPr lang="en-US" sz="1900" dirty="0"/>
+            <a:endParaRPr lang="en-US" sz="2200" dirty="0"/>
           </a:p>
         </p:txBody>
       </p:sp>
       <p:sp>
         <p:nvSpPr>
-          <p:cNvPr id="11" name="Chip 2"/>
-          <p:cNvSpPr/>
-          <p:nvPr/>
-        </p:nvSpPr>
-        <p:spPr>
-          <a:xfrm>
-            <a:off x="2984897" y="5591175"/>
-            <a:ext cx="1572071" cy="495300"/>
+          <p:cNvPr id="10" name="Chip 21 Level"/>
+          <p:cNvSpPr/>
+          <p:nvPr/>
+        </p:nvSpPr>
+        <p:spPr>
+          <a:xfrm>
+            <a:off x="3231654" y="3943350"/>
+            <a:ext cx="1528316" cy="590550"/>
           </a:xfrm>
           <a:prstGeom prst="roundRect">
             <a:avLst>
-              <a:gd name="adj" fmla="val 25846"/>
+              <a:gd name="adj" fmla="val 21677"/>
             </a:avLst>
           </a:prstGeom>
           <a:solidFill>
@@ -1204,14 +1165,14 @@
       </p:sp>
       <p:sp>
         <p:nvSpPr>
-          <p:cNvPr id="12" name="Chip-Text 2"/>
+          <p:cNvPr id="11" name="Chip-Text 21 Level"/>
           <p:cNvSpPr txBox="1"/>
           <p:nvPr/>
         </p:nvSpPr>
         <p:spPr>
           <a:xfrm>
-            <a:off x="2984897" y="5591175"/>
-            <a:ext cx="1572071" cy="495300"/>
+            <a:off x="3231654" y="3943350"/>
+            <a:ext cx="1528316" cy="590550"/>
           </a:xfrm>
           <a:prstGeom prst="rect">
             <a:avLst/>
@@ -1227,7 +1188,139 @@
               <a:buNone/>
             </a:pPr>
             <a:r>
-              <a:rPr lang="en-US" sz="1900" b="1" dirty="0">
+              <a:rPr lang="en-US" sz="2200" b="1" dirty="0">
+                <a:solidFill>
+                  <a:srgbClr val="B1FF37"/>
+                </a:solidFill>
+                <a:latin typeface="Poppins" pitchFamily="34" charset="0"/>
+                <a:ea typeface="Poppins" pitchFamily="34" charset="-122"/>
+                <a:cs typeface="Poppins" pitchFamily="34" charset="-120"/>
+              </a:rPr>
+              <a:t>21 Level</a:t>
+            </a:r>
+            <a:endParaRPr lang="en-US" sz="2200" dirty="0"/>
+          </a:p>
+        </p:txBody>
+      </p:sp>
+      <p:sp>
+        <p:nvSpPr>
+          <p:cNvPr id="12" name="Chip ohne Anmeldung"/>
+          <p:cNvSpPr/>
+          <p:nvPr/>
+        </p:nvSpPr>
+        <p:spPr>
+          <a:xfrm>
+            <a:off x="476250" y="4686300"/>
+            <a:ext cx="2886968" cy="590550"/>
+          </a:xfrm>
+          <a:prstGeom prst="roundRect">
+            <a:avLst>
+              <a:gd name="adj" fmla="val 21677"/>
+            </a:avLst>
+          </a:prstGeom>
+          <a:solidFill>
+            <a:srgbClr val="12301A"/>
+          </a:solidFill>
+          <a:ln w="12700">
+            <a:solidFill>
+              <a:srgbClr val="12301A"/>
+            </a:solidFill>
+            <a:prstDash val="solid"/>
+          </a:ln>
+        </p:spPr>
+      </p:sp>
+      <p:sp>
+        <p:nvSpPr>
+          <p:cNvPr id="13" name="Chip-Text ohne Anmeldung"/>
+          <p:cNvSpPr txBox="1"/>
+          <p:nvPr/>
+        </p:nvSpPr>
+        <p:spPr>
+          <a:xfrm>
+            <a:off x="476250" y="4686300"/>
+            <a:ext cx="2886968" cy="590550"/>
+          </a:xfrm>
+          <a:prstGeom prst="rect">
+            <a:avLst/>
+          </a:prstGeom>
+          <a:noFill/>
+          <a:ln/>
+        </p:spPr>
+        <p:txBody>
+          <a:bodyPr wrap="none" lIns="0" tIns="0" rIns="0" bIns="0" rtlCol="0" anchor="ctr"/>
+          <a:lstStyle/>
+          <a:p>
+            <a:pPr algn="ctr" indent="0" marL="0">
+              <a:buNone/>
+            </a:pPr>
+            <a:r>
+              <a:rPr lang="en-US" sz="2200" b="1" dirty="0">
+                <a:solidFill>
+                  <a:srgbClr val="B1FF37"/>
+                </a:solidFill>
+                <a:latin typeface="Poppins" pitchFamily="34" charset="0"/>
+                <a:ea typeface="Poppins" pitchFamily="34" charset="-122"/>
+                <a:cs typeface="Poppins" pitchFamily="34" charset="-120"/>
+              </a:rPr>
+              <a:t>ohne Anmeldung</a:t>
+            </a:r>
+            <a:endParaRPr lang="en-US" sz="2200" dirty="0"/>
+          </a:p>
+        </p:txBody>
+      </p:sp>
+      <p:sp>
+        <p:nvSpPr>
+          <p:cNvPr id="14" name="Chip kostenlos"/>
+          <p:cNvSpPr/>
+          <p:nvPr/>
+        </p:nvSpPr>
+        <p:spPr>
+          <a:xfrm>
+            <a:off x="3496568" y="4686300"/>
+            <a:ext cx="1790700" cy="590550"/>
+          </a:xfrm>
+          <a:prstGeom prst="roundRect">
+            <a:avLst>
+              <a:gd name="adj" fmla="val 21677"/>
+            </a:avLst>
+          </a:prstGeom>
+          <a:solidFill>
+            <a:srgbClr val="12301A"/>
+          </a:solidFill>
+          <a:ln w="12700">
+            <a:solidFill>
+              <a:srgbClr val="12301A"/>
+            </a:solidFill>
+            <a:prstDash val="solid"/>
+          </a:ln>
+        </p:spPr>
+      </p:sp>
+      <p:sp>
+        <p:nvSpPr>
+          <p:cNvPr id="15" name="Chip-Text kostenlos"/>
+          <p:cNvSpPr txBox="1"/>
+          <p:nvPr/>
+        </p:nvSpPr>
+        <p:spPr>
+          <a:xfrm>
+            <a:off x="3496568" y="4686300"/>
+            <a:ext cx="1790700" cy="590550"/>
+          </a:xfrm>
+          <a:prstGeom prst="rect">
+            <a:avLst/>
+          </a:prstGeom>
+          <a:noFill/>
+          <a:ln/>
+        </p:spPr>
+        <p:txBody>
+          <a:bodyPr wrap="none" lIns="0" tIns="0" rIns="0" bIns="0" rtlCol="0" anchor="ctr"/>
+          <a:lstStyle/>
+          <a:p>
+            <a:pPr algn="ctr" indent="0" marL="0">
+              <a:buNone/>
+            </a:pPr>
+            <a:r>
+              <a:rPr lang="en-US" sz="2200" b="1" dirty="0">
                 <a:solidFill>
                   <a:srgbClr val="B1FF37"/>
                 </a:solidFill>
@@ -1237,24 +1330,24 @@
               </a:rPr>
               <a:t>kostenlos</a:t>
             </a:r>
-            <a:endParaRPr lang="en-US" sz="1900" dirty="0"/>
+            <a:endParaRPr lang="en-US" sz="2200" dirty="0"/>
           </a:p>
         </p:txBody>
       </p:sp>
       <p:sp>
         <p:nvSpPr>
-          <p:cNvPr id="13" name="Fenster"/>
-          <p:cNvSpPr/>
-          <p:nvPr/>
-        </p:nvSpPr>
-        <p:spPr>
-          <a:xfrm>
-            <a:off x="6096000" y="762000"/>
-            <a:ext cx="5715000" cy="5238750"/>
+          <p:cNvPr id="16" name="Fenster"/>
+          <p:cNvSpPr/>
+          <p:nvPr/>
+        </p:nvSpPr>
+        <p:spPr>
+          <a:xfrm>
+            <a:off x="7581900" y="2695575"/>
+            <a:ext cx="4229100" cy="3876675"/>
           </a:xfrm>
           <a:prstGeom prst="roundRect">
             <a:avLst>
-              <a:gd name="adj" fmla="val 1222"/>
+              <a:gd name="adj" fmla="val 1651"/>
             </a:avLst>
           </a:prstGeom>
           <a:solidFill>
@@ -1270,18 +1363,18 @@
       </p:sp>
       <p:sp>
         <p:nvSpPr>
-          <p:cNvPr id="14" name="Fenster-Kopf"/>
-          <p:cNvSpPr/>
-          <p:nvPr/>
-        </p:nvSpPr>
-        <p:spPr>
-          <a:xfrm>
-            <a:off x="6096000" y="762000"/>
-            <a:ext cx="5715000" cy="533400"/>
+          <p:cNvPr id="17" name="Fenster-Kopf"/>
+          <p:cNvSpPr/>
+          <p:nvPr/>
+        </p:nvSpPr>
+        <p:spPr>
+          <a:xfrm>
+            <a:off x="7581900" y="2695575"/>
+            <a:ext cx="4229100" cy="394716"/>
           </a:xfrm>
           <a:prstGeom prst="roundRect">
             <a:avLst>
-              <a:gd name="adj" fmla="val 12000"/>
+              <a:gd name="adj" fmla="val 16216"/>
             </a:avLst>
           </a:prstGeom>
           <a:solidFill>
@@ -1297,14 +1390,14 @@
       </p:sp>
       <p:sp>
         <p:nvSpPr>
-          <p:cNvPr id="15" name="Fenster-Kopf-Füllung"/>
-          <p:cNvSpPr/>
-          <p:nvPr/>
-        </p:nvSpPr>
-        <p:spPr>
-          <a:xfrm>
-            <a:off x="6096000" y="1047750"/>
-            <a:ext cx="5715000" cy="247650"/>
+          <p:cNvPr id="18" name="Fenster-Kopf-Füllung"/>
+          <p:cNvSpPr/>
+          <p:nvPr/>
+        </p:nvSpPr>
+        <p:spPr>
+          <a:xfrm>
+            <a:off x="7581900" y="2907030"/>
+            <a:ext cx="4229100" cy="183261"/>
           </a:xfrm>
           <a:prstGeom prst="roundRect">
             <a:avLst/>
@@ -1322,14 +1415,14 @@
       </p:sp>
       <p:sp>
         <p:nvSpPr>
-          <p:cNvPr id="16" name="Fensterpunkt 1"/>
-          <p:cNvSpPr/>
-          <p:nvPr/>
-        </p:nvSpPr>
-        <p:spPr>
-          <a:xfrm>
-            <a:off x="6305550" y="952500"/>
-            <a:ext cx="152400" cy="152400"/>
+          <p:cNvPr id="19" name="Fensterpunkt 1"/>
+          <p:cNvSpPr/>
+          <p:nvPr/>
+        </p:nvSpPr>
+        <p:spPr>
+          <a:xfrm>
+            <a:off x="7736967" y="2836545"/>
+            <a:ext cx="112776" cy="112776"/>
           </a:xfrm>
           <a:prstGeom prst="ellipse">
             <a:avLst/>
@@ -1347,14 +1440,14 @@
       </p:sp>
       <p:sp>
         <p:nvSpPr>
-          <p:cNvPr id="17" name="Fensterpunkt 2"/>
-          <p:cNvSpPr/>
-          <p:nvPr/>
-        </p:nvSpPr>
-        <p:spPr>
-          <a:xfrm>
-            <a:off x="6553200" y="952500"/>
-            <a:ext cx="152400" cy="152400"/>
+          <p:cNvPr id="20" name="Fensterpunkt 2"/>
+          <p:cNvSpPr/>
+          <p:nvPr/>
+        </p:nvSpPr>
+        <p:spPr>
+          <a:xfrm>
+            <a:off x="7920228" y="2836545"/>
+            <a:ext cx="112776" cy="112776"/>
           </a:xfrm>
           <a:prstGeom prst="ellipse">
             <a:avLst/>
@@ -1372,14 +1465,14 @@
       </p:sp>
       <p:sp>
         <p:nvSpPr>
-          <p:cNvPr id="18" name="Fensterpunkt 3"/>
-          <p:cNvSpPr/>
-          <p:nvPr/>
-        </p:nvSpPr>
-        <p:spPr>
-          <a:xfrm>
-            <a:off x="6800850" y="952500"/>
-            <a:ext cx="152400" cy="152400"/>
+          <p:cNvPr id="21" name="Fensterpunkt 3"/>
+          <p:cNvSpPr/>
+          <p:nvPr/>
+        </p:nvSpPr>
+        <p:spPr>
+          <a:xfrm>
+            <a:off x="8103489" y="2836545"/>
+            <a:ext cx="112776" cy="112776"/>
           </a:xfrm>
           <a:prstGeom prst="ellipse">
             <a:avLst/>
@@ -1397,14 +1490,14 @@
       </p:sp>
       <p:sp>
         <p:nvSpPr>
-          <p:cNvPr id="19" name="Fenster-Titel"/>
+          <p:cNvPr id="22" name="Fenster-Titel"/>
           <p:cNvSpPr txBox="1"/>
           <p:nvPr/>
         </p:nvSpPr>
         <p:spPr>
           <a:xfrm>
-            <a:off x="7334250" y="762000"/>
-            <a:ext cx="4000500" cy="533400"/>
+            <a:off x="8498205" y="2695575"/>
+            <a:ext cx="2960370" cy="394716"/>
           </a:xfrm>
           <a:prstGeom prst="rect">
             <a:avLst/>
@@ -1420,7 +1513,7 @@
               <a:buNone/>
             </a:pPr>
             <a:r>
-              <a:rPr lang="en-US" sz="1500" b="1" dirty="0">
+              <a:rPr lang="en-US" sz="1100" b="1" dirty="0">
                 <a:solidFill>
                   <a:srgbClr val="B1FF37"/>
                 </a:solidFill>
@@ -1430,20 +1523,47 @@
               </a:rPr>
               <a:t>Programmieren</a:t>
             </a:r>
-            <a:endParaRPr lang="en-US" sz="1500" dirty="0"/>
+            <a:endParaRPr lang="en-US" sz="1100" dirty="0"/>
           </a:p>
         </p:txBody>
       </p:sp>
       <p:sp>
         <p:nvSpPr>
-          <p:cNvPr id="20" name="Spalte-Titel"/>
+          <p:cNvPr id="23" name="Block Wiederhole 1"/>
+          <p:cNvSpPr/>
+          <p:nvPr/>
+        </p:nvSpPr>
+        <p:spPr>
+          <a:xfrm>
+            <a:off x="7751064" y="3203067"/>
+            <a:ext cx="1663446" cy="789432"/>
+          </a:xfrm>
+          <a:prstGeom prst="roundRect">
+            <a:avLst>
+              <a:gd name="adj" fmla="val 13900"/>
+            </a:avLst>
+          </a:prstGeom>
+          <a:solidFill>
+            <a:srgbClr val="B1FF37"/>
+          </a:solidFill>
+          <a:ln w="12700">
+            <a:solidFill>
+              <a:srgbClr val="B1FF37"/>
+            </a:solidFill>
+            <a:prstDash val="solid"/>
+          </a:ln>
+        </p:spPr>
+      </p:sp>
+      <p:sp>
+        <p:nvSpPr>
+          <p:cNvPr id="24" name="Block Wiederhole 1 Text"/>
           <p:cNvSpPr txBox="1"/>
           <p:nvPr/>
         </p:nvSpPr>
         <p:spPr>
           <a:xfrm>
-            <a:off x="6324600" y="1390650"/>
-            <a:ext cx="2190750" cy="323850"/>
+            <a:off x="7849743" y="3217164"/>
+            <a:ext cx="1409700" cy="281940"/>
           </a:xfrm>
           <a:prstGeom prst="rect">
             <a:avLst/>
@@ -1459,73 +1579,7 @@
               <a:buNone/>
             </a:pPr>
             <a:r>
-              <a:rPr lang="en-US" sz="1200" b="1" dirty="0">
-                <a:solidFill>
-                  <a:srgbClr val="5B6B50"/>
-                </a:solidFill>
-                <a:latin typeface="Poppins" pitchFamily="34" charset="0"/>
-                <a:ea typeface="Poppins" pitchFamily="34" charset="-122"/>
-                <a:cs typeface="Poppins" pitchFamily="34" charset="-120"/>
-              </a:rPr>
-              <a:t>Dein Programm</a:t>
-            </a:r>
-            <a:endParaRPr lang="en-US" sz="1200" dirty="0"/>
-          </a:p>
-        </p:txBody>
-      </p:sp>
-      <p:sp>
-        <p:nvSpPr>
-          <p:cNvPr id="21" name="Block Wiederhole 1"/>
-          <p:cNvSpPr/>
-          <p:nvPr/>
-        </p:nvSpPr>
-        <p:spPr>
-          <a:xfrm>
-            <a:off x="6324600" y="1752600"/>
-            <a:ext cx="2247900" cy="1066800"/>
-          </a:xfrm>
-          <a:prstGeom prst="roundRect">
-            <a:avLst>
-              <a:gd name="adj" fmla="val 10286"/>
-            </a:avLst>
-          </a:prstGeom>
-          <a:solidFill>
-            <a:srgbClr val="B1FF37"/>
-          </a:solidFill>
-          <a:ln w="12700">
-            <a:solidFill>
-              <a:srgbClr val="B1FF37"/>
-            </a:solidFill>
-            <a:prstDash val="solid"/>
-          </a:ln>
-        </p:spPr>
-      </p:sp>
-      <p:sp>
-        <p:nvSpPr>
-          <p:cNvPr id="22" name="Block Wiederhole 1 Text"/>
-          <p:cNvSpPr txBox="1"/>
-          <p:nvPr/>
-        </p:nvSpPr>
-        <p:spPr>
-          <a:xfrm>
-            <a:off x="6457950" y="1771650"/>
-            <a:ext cx="1905000" cy="381000"/>
-          </a:xfrm>
-          <a:prstGeom prst="rect">
-            <a:avLst/>
-          </a:prstGeom>
-          <a:noFill/>
-          <a:ln/>
-        </p:spPr>
-        <p:txBody>
-          <a:bodyPr wrap="none" lIns="0" tIns="0" rIns="0" bIns="0" rtlCol="0" anchor="ctr"/>
-          <a:lstStyle/>
-          <a:p>
-            <a:pPr algn="l" indent="0" marL="0">
-              <a:buNone/>
-            </a:pPr>
-            <a:r>
-              <a:rPr lang="en-US" sz="1400" b="1" dirty="0">
+              <a:rPr lang="en-US" sz="1000" b="1" dirty="0">
                 <a:solidFill>
                   <a:srgbClr val="12301A"/>
                 </a:solidFill>
@@ -1535,24 +1589,24 @@
               </a:rPr>
               <a:t>Wiederhole 3 mal</a:t>
             </a:r>
-            <a:endParaRPr lang="en-US" sz="1400" dirty="0"/>
+            <a:endParaRPr lang="en-US" sz="1000" dirty="0"/>
           </a:p>
         </p:txBody>
       </p:sp>
       <p:sp>
         <p:nvSpPr>
-          <p:cNvPr id="23" name="Block Schritt 1"/>
-          <p:cNvSpPr/>
-          <p:nvPr/>
-        </p:nvSpPr>
-        <p:spPr>
-          <a:xfrm>
-            <a:off x="6515100" y="2171700"/>
-            <a:ext cx="1866900" cy="495300"/>
+          <p:cNvPr id="25" name="Block Schritt 1"/>
+          <p:cNvSpPr/>
+          <p:nvPr/>
+        </p:nvSpPr>
+        <p:spPr>
+          <a:xfrm>
+            <a:off x="7892034" y="3513201"/>
+            <a:ext cx="1381506" cy="366522"/>
           </a:xfrm>
           <a:prstGeom prst="roundRect">
             <a:avLst>
-              <a:gd name="adj" fmla="val 18462"/>
+              <a:gd name="adj" fmla="val 24948"/>
             </a:avLst>
           </a:prstGeom>
           <a:solidFill>
@@ -1568,14 +1622,14 @@
       </p:sp>
       <p:sp>
         <p:nvSpPr>
-          <p:cNvPr id="24" name="Block Schritt 1 Text"/>
+          <p:cNvPr id="26" name="Block Schritt 1 Text"/>
           <p:cNvSpPr txBox="1"/>
           <p:nvPr/>
         </p:nvSpPr>
         <p:spPr>
           <a:xfrm>
-            <a:off x="6648450" y="2171700"/>
-            <a:ext cx="1619250" cy="495300"/>
+            <a:off x="7990713" y="3513201"/>
+            <a:ext cx="1240536" cy="366522"/>
           </a:xfrm>
           <a:prstGeom prst="rect">
             <a:avLst/>
@@ -1591,7 +1645,7 @@
               <a:buNone/>
             </a:pPr>
             <a:r>
-              <a:rPr lang="en-US" sz="1200" b="1" dirty="0">
+              <a:rPr lang="en-US" sz="900" b="1" dirty="0">
                 <a:solidFill>
                   <a:srgbClr val="FFFFFF"/>
                 </a:solidFill>
@@ -1601,24 +1655,24 @@
               </a:rPr>
               <a:t>Schritt vorwärts</a:t>
             </a:r>
-            <a:endParaRPr lang="en-US" sz="1200" dirty="0"/>
+            <a:endParaRPr lang="en-US" sz="900" dirty="0"/>
           </a:p>
         </p:txBody>
       </p:sp>
       <p:sp>
         <p:nvSpPr>
-          <p:cNvPr id="25" name="Block Links"/>
-          <p:cNvSpPr/>
-          <p:nvPr/>
-        </p:nvSpPr>
-        <p:spPr>
-          <a:xfrm>
-            <a:off x="6324600" y="2933700"/>
-            <a:ext cx="2247900" cy="495300"/>
+          <p:cNvPr id="27" name="Block Links"/>
+          <p:cNvSpPr/>
+          <p:nvPr/>
+        </p:nvSpPr>
+        <p:spPr>
+          <a:xfrm>
+            <a:off x="7751064" y="4077081"/>
+            <a:ext cx="1663446" cy="366522"/>
           </a:xfrm>
           <a:prstGeom prst="roundRect">
             <a:avLst>
-              <a:gd name="adj" fmla="val 18462"/>
+              <a:gd name="adj" fmla="val 24948"/>
             </a:avLst>
           </a:prstGeom>
           <a:solidFill>
@@ -1634,14 +1688,14 @@
       </p:sp>
       <p:sp>
         <p:nvSpPr>
-          <p:cNvPr id="26" name="Block Links Text"/>
+          <p:cNvPr id="28" name="Block Links Text"/>
           <p:cNvSpPr txBox="1"/>
           <p:nvPr/>
         </p:nvSpPr>
         <p:spPr>
           <a:xfrm>
-            <a:off x="6457950" y="2933700"/>
-            <a:ext cx="1905000" cy="495300"/>
+            <a:off x="7849743" y="4077081"/>
+            <a:ext cx="1522476" cy="366522"/>
           </a:xfrm>
           <a:prstGeom prst="rect">
             <a:avLst/>
@@ -1657,7 +1711,7 @@
               <a:buNone/>
             </a:pPr>
             <a:r>
-              <a:rPr lang="en-US" sz="1200" b="1" dirty="0">
+              <a:rPr lang="en-US" sz="900" b="1" dirty="0">
                 <a:solidFill>
                   <a:srgbClr val="FFFFFF"/>
                 </a:solidFill>
@@ -1667,24 +1721,24 @@
               </a:rPr>
               <a:t>Links drehen</a:t>
             </a:r>
-            <a:endParaRPr lang="en-US" sz="1200" dirty="0"/>
+            <a:endParaRPr lang="en-US" sz="900" dirty="0"/>
           </a:p>
         </p:txBody>
       </p:sp>
       <p:sp>
         <p:nvSpPr>
-          <p:cNvPr id="27" name="Block Wiederhole 2"/>
-          <p:cNvSpPr/>
-          <p:nvPr/>
-        </p:nvSpPr>
-        <p:spPr>
-          <a:xfrm>
-            <a:off x="6324600" y="3543300"/>
-            <a:ext cx="2247900" cy="1066800"/>
+          <p:cNvPr id="29" name="Block Wiederhole 2"/>
+          <p:cNvSpPr/>
+          <p:nvPr/>
+        </p:nvSpPr>
+        <p:spPr>
+          <a:xfrm>
+            <a:off x="7751064" y="4528185"/>
+            <a:ext cx="1663446" cy="789432"/>
           </a:xfrm>
           <a:prstGeom prst="roundRect">
             <a:avLst>
-              <a:gd name="adj" fmla="val 10286"/>
+              <a:gd name="adj" fmla="val 13900"/>
             </a:avLst>
           </a:prstGeom>
           <a:solidFill>
@@ -1700,14 +1754,14 @@
       </p:sp>
       <p:sp>
         <p:nvSpPr>
-          <p:cNvPr id="28" name="Block Wiederhole 2 Text"/>
+          <p:cNvPr id="30" name="Block Wiederhole 2 Text"/>
           <p:cNvSpPr txBox="1"/>
           <p:nvPr/>
         </p:nvSpPr>
         <p:spPr>
           <a:xfrm>
-            <a:off x="6457950" y="3562350"/>
-            <a:ext cx="1905000" cy="381000"/>
+            <a:off x="7849743" y="4542282"/>
+            <a:ext cx="1409700" cy="281940"/>
           </a:xfrm>
           <a:prstGeom prst="rect">
             <a:avLst/>
@@ -1723,7 +1777,7 @@
               <a:buNone/>
             </a:pPr>
             <a:r>
-              <a:rPr lang="en-US" sz="1400" b="1" dirty="0">
+              <a:rPr lang="en-US" sz="1000" b="1" dirty="0">
                 <a:solidFill>
                   <a:srgbClr val="12301A"/>
                 </a:solidFill>
@@ -1733,24 +1787,24 @@
               </a:rPr>
               <a:t>Wiederhole 3 mal</a:t>
             </a:r>
-            <a:endParaRPr lang="en-US" sz="1400" dirty="0"/>
+            <a:endParaRPr lang="en-US" sz="1000" dirty="0"/>
           </a:p>
         </p:txBody>
       </p:sp>
       <p:sp>
         <p:nvSpPr>
-          <p:cNvPr id="29" name="Block Schritt 2"/>
-          <p:cNvSpPr/>
-          <p:nvPr/>
-        </p:nvSpPr>
-        <p:spPr>
-          <a:xfrm>
-            <a:off x="6515100" y="3962400"/>
-            <a:ext cx="1866900" cy="495300"/>
+          <p:cNvPr id="31" name="Block Schritt 2"/>
+          <p:cNvSpPr/>
+          <p:nvPr/>
+        </p:nvSpPr>
+        <p:spPr>
+          <a:xfrm>
+            <a:off x="7892034" y="4838319"/>
+            <a:ext cx="1381506" cy="366522"/>
           </a:xfrm>
           <a:prstGeom prst="roundRect">
             <a:avLst>
-              <a:gd name="adj" fmla="val 18462"/>
+              <a:gd name="adj" fmla="val 24948"/>
             </a:avLst>
           </a:prstGeom>
           <a:solidFill>
@@ -1766,14 +1820,14 @@
       </p:sp>
       <p:sp>
         <p:nvSpPr>
-          <p:cNvPr id="30" name="Block Schritt 2 Text"/>
+          <p:cNvPr id="32" name="Block Schritt 2 Text"/>
           <p:cNvSpPr txBox="1"/>
           <p:nvPr/>
         </p:nvSpPr>
         <p:spPr>
           <a:xfrm>
-            <a:off x="6648450" y="3962400"/>
-            <a:ext cx="1619250" cy="495300"/>
+            <a:off x="7990713" y="4838319"/>
+            <a:ext cx="1240536" cy="366522"/>
           </a:xfrm>
           <a:prstGeom prst="rect">
             <a:avLst/>
@@ -1789,7 +1843,7 @@
               <a:buNone/>
             </a:pPr>
             <a:r>
-              <a:rPr lang="en-US" sz="1200" b="1" dirty="0">
+              <a:rPr lang="en-US" sz="900" b="1" dirty="0">
                 <a:solidFill>
                   <a:srgbClr val="FFFFFF"/>
                 </a:solidFill>
@@ -1799,20 +1853,20 @@
               </a:rPr>
               <a:t>Schritt vorwärts</a:t>
             </a:r>
-            <a:endParaRPr lang="en-US" sz="1200" dirty="0"/>
+            <a:endParaRPr lang="en-US" sz="900" dirty="0"/>
           </a:p>
         </p:txBody>
       </p:sp>
       <p:sp>
         <p:nvSpPr>
-          <p:cNvPr id="31" name="Feld 1-1"/>
-          <p:cNvSpPr/>
-          <p:nvPr/>
-        </p:nvSpPr>
-        <p:spPr>
-          <a:xfrm>
-            <a:off x="8877300" y="1828800"/>
-            <a:ext cx="723900" cy="723900"/>
+          <p:cNvPr id="33" name="Feld 1-1"/>
+          <p:cNvSpPr/>
+          <p:nvPr/>
+        </p:nvSpPr>
+        <p:spPr>
+          <a:xfrm>
+            <a:off x="9640062" y="3259455"/>
+            <a:ext cx="535686" cy="535686"/>
           </a:xfrm>
           <a:prstGeom prst="roundRect">
             <a:avLst/>
@@ -1830,14 +1884,14 @@
       </p:sp>
       <p:sp>
         <p:nvSpPr>
-          <p:cNvPr id="32" name="Feld 1-2"/>
-          <p:cNvSpPr/>
-          <p:nvPr/>
-        </p:nvSpPr>
-        <p:spPr>
-          <a:xfrm>
-            <a:off x="9601200" y="1828800"/>
-            <a:ext cx="723900" cy="723900"/>
+          <p:cNvPr id="34" name="Feld 1-2"/>
+          <p:cNvSpPr/>
+          <p:nvPr/>
+        </p:nvSpPr>
+        <p:spPr>
+          <a:xfrm>
+            <a:off x="10175748" y="3259455"/>
+            <a:ext cx="535686" cy="535686"/>
           </a:xfrm>
           <a:prstGeom prst="roundRect">
             <a:avLst/>
@@ -1855,14 +1909,14 @@
       </p:sp>
       <p:sp>
         <p:nvSpPr>
-          <p:cNvPr id="33" name="Feld 1-3"/>
-          <p:cNvSpPr/>
-          <p:nvPr/>
-        </p:nvSpPr>
-        <p:spPr>
-          <a:xfrm>
-            <a:off x="10325100" y="1828800"/>
-            <a:ext cx="723900" cy="723900"/>
+          <p:cNvPr id="35" name="Feld 1-3"/>
+          <p:cNvSpPr/>
+          <p:nvPr/>
+        </p:nvSpPr>
+        <p:spPr>
+          <a:xfrm>
+            <a:off x="10711434" y="3259455"/>
+            <a:ext cx="535686" cy="535686"/>
           </a:xfrm>
           <a:prstGeom prst="roundRect">
             <a:avLst/>
@@ -1880,14 +1934,14 @@
       </p:sp>
       <p:sp>
         <p:nvSpPr>
-          <p:cNvPr id="34" name="Feld 1-4"/>
-          <p:cNvSpPr/>
-          <p:nvPr/>
-        </p:nvSpPr>
-        <p:spPr>
-          <a:xfrm>
-            <a:off x="11049000" y="1828800"/>
-            <a:ext cx="723900" cy="723900"/>
+          <p:cNvPr id="36" name="Feld 1-4"/>
+          <p:cNvSpPr/>
+          <p:nvPr/>
+        </p:nvSpPr>
+        <p:spPr>
+          <a:xfrm>
+            <a:off x="11247120" y="3259455"/>
+            <a:ext cx="535686" cy="535686"/>
           </a:xfrm>
           <a:prstGeom prst="roundRect">
             <a:avLst/>
@@ -1905,14 +1959,14 @@
       </p:sp>
       <p:sp>
         <p:nvSpPr>
-          <p:cNvPr id="35" name="Feld 2-1"/>
-          <p:cNvSpPr/>
-          <p:nvPr/>
-        </p:nvSpPr>
-        <p:spPr>
-          <a:xfrm>
-            <a:off x="8877300" y="2552700"/>
-            <a:ext cx="723900" cy="723900"/>
+          <p:cNvPr id="37" name="Feld 2-1"/>
+          <p:cNvSpPr/>
+          <p:nvPr/>
+        </p:nvSpPr>
+        <p:spPr>
+          <a:xfrm>
+            <a:off x="9640062" y="3795141"/>
+            <a:ext cx="535686" cy="535686"/>
           </a:xfrm>
           <a:prstGeom prst="roundRect">
             <a:avLst/>
@@ -1930,14 +1984,14 @@
       </p:sp>
       <p:sp>
         <p:nvSpPr>
-          <p:cNvPr id="36" name="Feld 2-2"/>
-          <p:cNvSpPr/>
-          <p:nvPr/>
-        </p:nvSpPr>
-        <p:spPr>
-          <a:xfrm>
-            <a:off x="9601200" y="2552700"/>
-            <a:ext cx="723900" cy="723900"/>
+          <p:cNvPr id="38" name="Feld 2-2"/>
+          <p:cNvSpPr/>
+          <p:nvPr/>
+        </p:nvSpPr>
+        <p:spPr>
+          <a:xfrm>
+            <a:off x="10175748" y="3795141"/>
+            <a:ext cx="535686" cy="535686"/>
           </a:xfrm>
           <a:prstGeom prst="roundRect">
             <a:avLst/>
@@ -1955,14 +2009,14 @@
       </p:sp>
       <p:sp>
         <p:nvSpPr>
-          <p:cNvPr id="37" name="Feld 2-3"/>
-          <p:cNvSpPr/>
-          <p:nvPr/>
-        </p:nvSpPr>
-        <p:spPr>
-          <a:xfrm>
-            <a:off x="10325100" y="2552700"/>
-            <a:ext cx="723900" cy="723900"/>
+          <p:cNvPr id="39" name="Feld 2-3"/>
+          <p:cNvSpPr/>
+          <p:nvPr/>
+        </p:nvSpPr>
+        <p:spPr>
+          <a:xfrm>
+            <a:off x="10711434" y="3795141"/>
+            <a:ext cx="535686" cy="535686"/>
           </a:xfrm>
           <a:prstGeom prst="roundRect">
             <a:avLst/>
@@ -1980,14 +2034,14 @@
       </p:sp>
       <p:sp>
         <p:nvSpPr>
-          <p:cNvPr id="38" name="Feld 2-4"/>
-          <p:cNvSpPr/>
-          <p:nvPr/>
-        </p:nvSpPr>
-        <p:spPr>
-          <a:xfrm>
-            <a:off x="11049000" y="2552700"/>
-            <a:ext cx="723900" cy="723900"/>
+          <p:cNvPr id="40" name="Feld 2-4"/>
+          <p:cNvSpPr/>
+          <p:nvPr/>
+        </p:nvSpPr>
+        <p:spPr>
+          <a:xfrm>
+            <a:off x="11247120" y="3795141"/>
+            <a:ext cx="535686" cy="535686"/>
           </a:xfrm>
           <a:prstGeom prst="roundRect">
             <a:avLst/>
@@ -2005,14 +2059,14 @@
       </p:sp>
       <p:sp>
         <p:nvSpPr>
-          <p:cNvPr id="39" name="Feld 3-1"/>
-          <p:cNvSpPr/>
-          <p:nvPr/>
-        </p:nvSpPr>
-        <p:spPr>
-          <a:xfrm>
-            <a:off x="8877300" y="3276600"/>
-            <a:ext cx="723900" cy="723900"/>
+          <p:cNvPr id="41" name="Feld 3-1"/>
+          <p:cNvSpPr/>
+          <p:nvPr/>
+        </p:nvSpPr>
+        <p:spPr>
+          <a:xfrm>
+            <a:off x="9640062" y="4330827"/>
+            <a:ext cx="535686" cy="535686"/>
           </a:xfrm>
           <a:prstGeom prst="roundRect">
             <a:avLst/>
@@ -2030,14 +2084,14 @@
       </p:sp>
       <p:sp>
         <p:nvSpPr>
-          <p:cNvPr id="40" name="Feld 3-2"/>
-          <p:cNvSpPr/>
-          <p:nvPr/>
-        </p:nvSpPr>
-        <p:spPr>
-          <a:xfrm>
-            <a:off x="9601200" y="3276600"/>
-            <a:ext cx="723900" cy="723900"/>
+          <p:cNvPr id="42" name="Feld 3-2"/>
+          <p:cNvSpPr/>
+          <p:nvPr/>
+        </p:nvSpPr>
+        <p:spPr>
+          <a:xfrm>
+            <a:off x="10175748" y="4330827"/>
+            <a:ext cx="535686" cy="535686"/>
           </a:xfrm>
           <a:prstGeom prst="roundRect">
             <a:avLst/>
@@ -2055,14 +2109,14 @@
       </p:sp>
       <p:sp>
         <p:nvSpPr>
-          <p:cNvPr id="41" name="Feld 3-3"/>
-          <p:cNvSpPr/>
-          <p:nvPr/>
-        </p:nvSpPr>
-        <p:spPr>
-          <a:xfrm>
-            <a:off x="10325100" y="3276600"/>
-            <a:ext cx="723900" cy="723900"/>
+          <p:cNvPr id="43" name="Feld 3-3"/>
+          <p:cNvSpPr/>
+          <p:nvPr/>
+        </p:nvSpPr>
+        <p:spPr>
+          <a:xfrm>
+            <a:off x="10711434" y="4330827"/>
+            <a:ext cx="535686" cy="535686"/>
           </a:xfrm>
           <a:prstGeom prst="roundRect">
             <a:avLst/>
@@ -2080,14 +2134,14 @@
       </p:sp>
       <p:sp>
         <p:nvSpPr>
-          <p:cNvPr id="42" name="Feld 3-4"/>
-          <p:cNvSpPr/>
-          <p:nvPr/>
-        </p:nvSpPr>
-        <p:spPr>
-          <a:xfrm>
-            <a:off x="11049000" y="3276600"/>
-            <a:ext cx="723900" cy="723900"/>
+          <p:cNvPr id="44" name="Feld 3-4"/>
+          <p:cNvSpPr/>
+          <p:nvPr/>
+        </p:nvSpPr>
+        <p:spPr>
+          <a:xfrm>
+            <a:off x="11247120" y="4330827"/>
+            <a:ext cx="535686" cy="535686"/>
           </a:xfrm>
           <a:prstGeom prst="roundRect">
             <a:avLst/>
@@ -2105,14 +2159,14 @@
       </p:sp>
       <p:sp>
         <p:nvSpPr>
-          <p:cNvPr id="43" name="Feld 4-1"/>
-          <p:cNvSpPr/>
-          <p:nvPr/>
-        </p:nvSpPr>
-        <p:spPr>
-          <a:xfrm>
-            <a:off x="8877300" y="4000500"/>
-            <a:ext cx="723900" cy="723900"/>
+          <p:cNvPr id="45" name="Feld 4-1"/>
+          <p:cNvSpPr/>
+          <p:nvPr/>
+        </p:nvSpPr>
+        <p:spPr>
+          <a:xfrm>
+            <a:off x="9640062" y="4866513"/>
+            <a:ext cx="535686" cy="535686"/>
           </a:xfrm>
           <a:prstGeom prst="roundRect">
             <a:avLst/>
@@ -2130,14 +2184,14 @@
       </p:sp>
       <p:sp>
         <p:nvSpPr>
-          <p:cNvPr id="44" name="Feld 4-2"/>
-          <p:cNvSpPr/>
-          <p:nvPr/>
-        </p:nvSpPr>
-        <p:spPr>
-          <a:xfrm>
-            <a:off x="9601200" y="4000500"/>
-            <a:ext cx="723900" cy="723900"/>
+          <p:cNvPr id="46" name="Feld 4-2"/>
+          <p:cNvSpPr/>
+          <p:nvPr/>
+        </p:nvSpPr>
+        <p:spPr>
+          <a:xfrm>
+            <a:off x="10175748" y="4866513"/>
+            <a:ext cx="535686" cy="535686"/>
           </a:xfrm>
           <a:prstGeom prst="roundRect">
             <a:avLst/>
@@ -2155,14 +2209,14 @@
       </p:sp>
       <p:sp>
         <p:nvSpPr>
-          <p:cNvPr id="45" name="Feld 4-3"/>
-          <p:cNvSpPr/>
-          <p:nvPr/>
-        </p:nvSpPr>
-        <p:spPr>
-          <a:xfrm>
-            <a:off x="10325100" y="4000500"/>
-            <a:ext cx="723900" cy="723900"/>
+          <p:cNvPr id="47" name="Feld 4-3"/>
+          <p:cNvSpPr/>
+          <p:nvPr/>
+        </p:nvSpPr>
+        <p:spPr>
+          <a:xfrm>
+            <a:off x="10711434" y="4866513"/>
+            <a:ext cx="535686" cy="535686"/>
           </a:xfrm>
           <a:prstGeom prst="roundRect">
             <a:avLst/>
@@ -2180,14 +2234,14 @@
       </p:sp>
       <p:sp>
         <p:nvSpPr>
-          <p:cNvPr id="46" name="Feld 4-4"/>
-          <p:cNvSpPr/>
-          <p:nvPr/>
-        </p:nvSpPr>
-        <p:spPr>
-          <a:xfrm>
-            <a:off x="11049000" y="4000500"/>
-            <a:ext cx="723900" cy="723900"/>
+          <p:cNvPr id="48" name="Feld 4-4"/>
+          <p:cNvSpPr/>
+          <p:nvPr/>
+        </p:nvSpPr>
+        <p:spPr>
+          <a:xfrm>
+            <a:off x="11247120" y="4866513"/>
+            <a:ext cx="535686" cy="535686"/>
           </a:xfrm>
           <a:prstGeom prst="roundRect">
             <a:avLst/>
@@ -2205,14 +2259,14 @@
       </p:sp>
       <p:sp>
         <p:nvSpPr>
-          <p:cNvPr id="47" name="Weg 1"/>
-          <p:cNvSpPr/>
-          <p:nvPr/>
-        </p:nvSpPr>
-        <p:spPr>
-          <a:xfrm>
-            <a:off x="11344275" y="3571875"/>
-            <a:ext cx="133350" cy="133350"/>
+          <p:cNvPr id="49" name="Weg 1"/>
+          <p:cNvSpPr/>
+          <p:nvPr/>
+        </p:nvSpPr>
+        <p:spPr>
+          <a:xfrm>
+            <a:off x="11465623" y="4549331"/>
+            <a:ext cx="98679" cy="98679"/>
           </a:xfrm>
           <a:prstGeom prst="ellipse">
             <a:avLst/>
@@ -2230,14 +2284,14 @@
       </p:sp>
       <p:sp>
         <p:nvSpPr>
-          <p:cNvPr id="48" name="Weg 2"/>
-          <p:cNvSpPr/>
-          <p:nvPr/>
-        </p:nvSpPr>
-        <p:spPr>
-          <a:xfrm>
-            <a:off x="11344275" y="2847975"/>
-            <a:ext cx="133350" cy="133350"/>
+          <p:cNvPr id="50" name="Weg 2"/>
+          <p:cNvSpPr/>
+          <p:nvPr/>
+        </p:nvSpPr>
+        <p:spPr>
+          <a:xfrm>
+            <a:off x="11465623" y="4013645"/>
+            <a:ext cx="98679" cy="98679"/>
           </a:xfrm>
           <a:prstGeom prst="ellipse">
             <a:avLst/>
@@ -2255,14 +2309,14 @@
       </p:sp>
       <p:sp>
         <p:nvSpPr>
-          <p:cNvPr id="49" name="Weg 3"/>
-          <p:cNvSpPr/>
-          <p:nvPr/>
-        </p:nvSpPr>
-        <p:spPr>
-          <a:xfrm>
-            <a:off x="11344275" y="2124075"/>
-            <a:ext cx="133350" cy="133350"/>
+          <p:cNvPr id="51" name="Weg 3"/>
+          <p:cNvSpPr/>
+          <p:nvPr/>
+        </p:nvSpPr>
+        <p:spPr>
+          <a:xfrm>
+            <a:off x="11465623" y="3477958"/>
+            <a:ext cx="98679" cy="98679"/>
           </a:xfrm>
           <a:prstGeom prst="ellipse">
             <a:avLst/>
@@ -2280,14 +2334,14 @@
       </p:sp>
       <p:sp>
         <p:nvSpPr>
-          <p:cNvPr id="50" name="Weg 4"/>
-          <p:cNvSpPr/>
-          <p:nvPr/>
-        </p:nvSpPr>
-        <p:spPr>
-          <a:xfrm>
-            <a:off x="10620375" y="2124075"/>
-            <a:ext cx="133350" cy="133350"/>
+          <p:cNvPr id="52" name="Weg 4"/>
+          <p:cNvSpPr/>
+          <p:nvPr/>
+        </p:nvSpPr>
+        <p:spPr>
+          <a:xfrm>
+            <a:off x="10929937" y="3477958"/>
+            <a:ext cx="98679" cy="98679"/>
           </a:xfrm>
           <a:prstGeom prst="ellipse">
             <a:avLst/>
@@ -2305,14 +2359,14 @@
       </p:sp>
       <p:sp>
         <p:nvSpPr>
-          <p:cNvPr id="51" name="Weg 5"/>
-          <p:cNvSpPr/>
-          <p:nvPr/>
-        </p:nvSpPr>
-        <p:spPr>
-          <a:xfrm>
-            <a:off x="9896475" y="2124075"/>
-            <a:ext cx="133350" cy="133350"/>
+          <p:cNvPr id="53" name="Weg 5"/>
+          <p:cNvSpPr/>
+          <p:nvPr/>
+        </p:nvSpPr>
+        <p:spPr>
+          <a:xfrm>
+            <a:off x="10394251" y="3477958"/>
+            <a:ext cx="98679" cy="98679"/>
           </a:xfrm>
           <a:prstGeom prst="ellipse">
             <a:avLst/>
@@ -2330,18 +2384,18 @@
       </p:sp>
       <p:sp>
         <p:nvSpPr>
-          <p:cNvPr id="52" name="Roboter Körper"/>
-          <p:cNvSpPr/>
-          <p:nvPr/>
-        </p:nvSpPr>
-        <p:spPr>
-          <a:xfrm>
-            <a:off x="11163300" y="4133850"/>
-            <a:ext cx="495300" cy="400050"/>
+          <p:cNvPr id="54" name="Roboter Körper"/>
+          <p:cNvSpPr/>
+          <p:nvPr/>
+        </p:nvSpPr>
+        <p:spPr>
+          <a:xfrm>
+            <a:off x="11331702" y="4965192"/>
+            <a:ext cx="366522" cy="296037"/>
           </a:xfrm>
           <a:prstGeom prst="roundRect">
             <a:avLst>
-              <a:gd name="adj" fmla="val 36571"/>
+              <a:gd name="adj" fmla="val 37066"/>
             </a:avLst>
           </a:prstGeom>
           <a:solidFill>
@@ -2357,14 +2411,14 @@
       </p:sp>
       <p:sp>
         <p:nvSpPr>
-          <p:cNvPr id="53" name="Roboter Auge 1"/>
-          <p:cNvSpPr/>
-          <p:nvPr/>
-        </p:nvSpPr>
-        <p:spPr>
-          <a:xfrm>
-            <a:off x="11268075" y="4229100"/>
-            <a:ext cx="95250" cy="95250"/>
+          <p:cNvPr id="55" name="Roboter Auge 1"/>
+          <p:cNvSpPr/>
+          <p:nvPr/>
+        </p:nvSpPr>
+        <p:spPr>
+          <a:xfrm>
+            <a:off x="11409236" y="5035677"/>
+            <a:ext cx="70485" cy="70485"/>
           </a:xfrm>
           <a:prstGeom prst="ellipse">
             <a:avLst/>
@@ -2382,14 +2436,14 @@
       </p:sp>
       <p:sp>
         <p:nvSpPr>
-          <p:cNvPr id="54" name="Roboter Auge 2"/>
-          <p:cNvSpPr/>
-          <p:nvPr/>
-        </p:nvSpPr>
-        <p:spPr>
-          <a:xfrm>
-            <a:off x="11458575" y="4229100"/>
-            <a:ext cx="95250" cy="95250"/>
+          <p:cNvPr id="56" name="Roboter Auge 2"/>
+          <p:cNvSpPr/>
+          <p:nvPr/>
+        </p:nvSpPr>
+        <p:spPr>
+          <a:xfrm>
+            <a:off x="11550206" y="5035677"/>
+            <a:ext cx="70485" cy="70485"/>
           </a:xfrm>
           <a:prstGeom prst="ellipse">
             <a:avLst/>
@@ -2407,14 +2461,14 @@
       </p:sp>
       <p:sp>
         <p:nvSpPr>
-          <p:cNvPr id="55" name="Antenne Punkt"/>
-          <p:cNvSpPr/>
-          <p:nvPr/>
-        </p:nvSpPr>
-        <p:spPr>
-          <a:xfrm>
-            <a:off x="11363325" y="4038600"/>
-            <a:ext cx="95250" cy="95250"/>
+          <p:cNvPr id="57" name="Antenne Punkt"/>
+          <p:cNvSpPr/>
+          <p:nvPr/>
+        </p:nvSpPr>
+        <p:spPr>
+          <a:xfrm>
+            <a:off x="11479721" y="4894707"/>
+            <a:ext cx="70485" cy="70485"/>
           </a:xfrm>
           <a:prstGeom prst="ellipse">
             <a:avLst/>
@@ -2432,14 +2486,14 @@
       </p:sp>
       <p:sp>
         <p:nvSpPr>
-          <p:cNvPr id="56" name="Fahnenmast"/>
-          <p:cNvSpPr/>
-          <p:nvPr/>
-        </p:nvSpPr>
-        <p:spPr>
-          <a:xfrm>
-            <a:off x="9086850" y="1924050"/>
-            <a:ext cx="47625" cy="533400"/>
+          <p:cNvPr id="58" name="Fahnenmast"/>
+          <p:cNvSpPr/>
+          <p:nvPr/>
+        </p:nvSpPr>
+        <p:spPr>
+          <a:xfrm>
+            <a:off x="9795129" y="3329940"/>
+            <a:ext cx="35243" cy="394716"/>
           </a:xfrm>
           <a:prstGeom prst="roundRect">
             <a:avLst/>
@@ -2457,14 +2511,14 @@
       </p:sp>
       <p:sp>
         <p:nvSpPr>
-          <p:cNvPr id="57" name="Fahne"/>
+          <p:cNvPr id="59" name="Fahne"/>
           <p:cNvSpPr/>
           <p:nvPr/>
         </p:nvSpPr>
         <p:spPr>
           <a:xfrm rot="5400000">
-            <a:off x="9134475" y="1924050"/>
-            <a:ext cx="323850" cy="228600"/>
+            <a:off x="9830372" y="3329940"/>
+            <a:ext cx="239649" cy="169164"/>
           </a:xfrm>
           <a:prstGeom prst="triangle">
             <a:avLst/>
@@ -2482,18 +2536,18 @@
       </p:sp>
       <p:sp>
         <p:nvSpPr>
-          <p:cNvPr id="58" name="Start-Knopf"/>
-          <p:cNvSpPr/>
-          <p:nvPr/>
-        </p:nvSpPr>
-        <p:spPr>
-          <a:xfrm>
-            <a:off x="8877300" y="4857750"/>
-            <a:ext cx="2895600" cy="609600"/>
+          <p:cNvPr id="60" name="Start-Knopf"/>
+          <p:cNvSpPr/>
+          <p:nvPr/>
+        </p:nvSpPr>
+        <p:spPr>
+          <a:xfrm>
+            <a:off x="9640062" y="5796915"/>
+            <a:ext cx="2142744" cy="422910"/>
           </a:xfrm>
           <a:prstGeom prst="roundRect">
             <a:avLst>
-              <a:gd name="adj" fmla="val 21000"/>
+              <a:gd name="adj" fmla="val 30270"/>
             </a:avLst>
           </a:prstGeom>
           <a:solidFill>
@@ -2509,14 +2563,14 @@
       </p:sp>
       <p:sp>
         <p:nvSpPr>
-          <p:cNvPr id="59" name="Start-Knopf-Text"/>
+          <p:cNvPr id="61" name="Start-Knopf-Text"/>
           <p:cNvSpPr txBox="1"/>
           <p:nvPr/>
         </p:nvSpPr>
         <p:spPr>
           <a:xfrm>
-            <a:off x="8877300" y="4857750"/>
-            <a:ext cx="2895600" cy="609600"/>
+            <a:off x="9640062" y="5796915"/>
+            <a:ext cx="2142744" cy="422910"/>
           </a:xfrm>
           <a:prstGeom prst="rect">
             <a:avLst/>
@@ -2532,7 +2586,7 @@
               <a:buNone/>
             </a:pPr>
             <a:r>
-              <a:rPr lang="en-US" sz="1900" b="1" dirty="0">
+              <a:rPr lang="en-US" sz="1400" b="1" dirty="0">
                 <a:solidFill>
                   <a:srgbClr val="FFFFFF"/>
                 </a:solidFill>
@@ -2542,24 +2596,24 @@
               </a:rPr>
               <a:t>Start</a:t>
             </a:r>
-            <a:endParaRPr lang="en-US" sz="1900" dirty="0"/>
+            <a:endParaRPr lang="en-US" sz="1400" dirty="0"/>
           </a:p>
         </p:txBody>
       </p:sp>
       <p:sp>
         <p:nvSpPr>
-          <p:cNvPr id="60" name="Hinweis"/>
-          <p:cNvSpPr/>
-          <p:nvPr/>
-        </p:nvSpPr>
-        <p:spPr>
-          <a:xfrm>
-            <a:off x="6324600" y="4857750"/>
-            <a:ext cx="2247900" cy="609600"/>
+          <p:cNvPr id="62" name="Hinweis"/>
+          <p:cNvSpPr/>
+          <p:nvPr/>
+        </p:nvSpPr>
+        <p:spPr>
+          <a:xfrm>
+            <a:off x="7751064" y="5796915"/>
+            <a:ext cx="1663446" cy="422910"/>
           </a:xfrm>
           <a:prstGeom prst="roundRect">
             <a:avLst>
-              <a:gd name="adj" fmla="val 18000"/>
+              <a:gd name="adj" fmla="val 25946"/>
             </a:avLst>
           </a:prstGeom>
           <a:solidFill>
@@ -2575,14 +2629,14 @@
       </p:sp>
       <p:sp>
         <p:nvSpPr>
-          <p:cNvPr id="61" name="Hinweis-Text"/>
+          <p:cNvPr id="63" name="Hinweis-Text"/>
           <p:cNvSpPr txBox="1"/>
           <p:nvPr/>
         </p:nvSpPr>
         <p:spPr>
           <a:xfrm>
-            <a:off x="6324600" y="4857750"/>
-            <a:ext cx="2247900" cy="609600"/>
+            <a:off x="7751064" y="5796915"/>
+            <a:ext cx="1663446" cy="422910"/>
           </a:xfrm>
           <a:prstGeom prst="rect">
             <a:avLst/>
@@ -2598,7 +2652,7 @@
               <a:buNone/>
             </a:pPr>
             <a:r>
-              <a:rPr lang="en-US" sz="1500" b="1" dirty="0">
+              <a:rPr lang="en-US" sz="1100" b="1" dirty="0">
                 <a:solidFill>
                   <a:srgbClr val="12301A"/>
                 </a:solidFill>
@@ -2608,7 +2662,7 @@
               </a:rPr>
               <a:t>5 Blöcke</a:t>
             </a:r>
-            <a:endParaRPr lang="en-US" sz="1500" dirty="0"/>
+            <a:endParaRPr lang="en-US" sz="1100" dirty="0"/>
           </a:p>
         </p:txBody>
       </p:sp>

</xml_diff>